<commit_message>
Residual updates after 24/25, part 2
Various minor updates
</commit_message>
<xml_diff>
--- a/Chap/Database/Presentations/SQL/DBSQL_Intro.pptx
+++ b/Chap/Database/Presentations/SQL/DBSQL_Intro.pptx
@@ -256,7 +256,7 @@
           <a:p>
             <a:fld id="{E15B7D8E-2A20-4C0E-991C-872DBB7459A8}" type="datetimeFigureOut">
               <a:rPr lang="da-DK" smtClean="0"/>
-              <a:t>06-02-2025</a:t>
+              <a:t>26-02-2025</a:t>
             </a:fld>
             <a:endParaRPr lang="da-DK"/>
           </a:p>
@@ -314,13 +314,13 @@
   <p:clrMapOvr>
     <a:masterClrMapping/>
   </p:clrMapOvr>
-  <mc:AlternateContent xmlns:mc="http://schemas.openxmlformats.org/markup-compatibility/2006">
-    <mc:Choice xmlns:p14="http://schemas.microsoft.com/office/powerpoint/2010/main" Requires="p14">
+  <mc:AlternateContent xmlns:mc="http://schemas.openxmlformats.org/markup-compatibility/2006" xmlns:p14="http://schemas.microsoft.com/office/powerpoint/2010/main">
+    <mc:Choice Requires="p14">
       <p:transition spd="med" p14:dur="700">
         <p:fade/>
       </p:transition>
     </mc:Choice>
-    <mc:Fallback>
+    <mc:Fallback xmlns="">
       <p:transition spd="med">
         <p:fade/>
       </p:transition>
@@ -436,7 +436,7 @@
           <a:p>
             <a:fld id="{E15B7D8E-2A20-4C0E-991C-872DBB7459A8}" type="datetimeFigureOut">
               <a:rPr lang="da-DK" smtClean="0"/>
-              <a:t>06-02-2025</a:t>
+              <a:t>26-02-2025</a:t>
             </a:fld>
             <a:endParaRPr lang="da-DK"/>
           </a:p>
@@ -494,13 +494,13 @@
   <p:clrMapOvr>
     <a:masterClrMapping/>
   </p:clrMapOvr>
-  <mc:AlternateContent xmlns:mc="http://schemas.openxmlformats.org/markup-compatibility/2006">
-    <mc:Choice xmlns:p14="http://schemas.microsoft.com/office/powerpoint/2010/main" Requires="p14">
+  <mc:AlternateContent xmlns:mc="http://schemas.openxmlformats.org/markup-compatibility/2006" xmlns:p14="http://schemas.microsoft.com/office/powerpoint/2010/main">
+    <mc:Choice Requires="p14">
       <p:transition spd="med" p14:dur="700">
         <p:fade/>
       </p:transition>
     </mc:Choice>
-    <mc:Fallback>
+    <mc:Fallback xmlns="">
       <p:transition spd="med">
         <p:fade/>
       </p:transition>
@@ -626,7 +626,7 @@
           <a:p>
             <a:fld id="{E15B7D8E-2A20-4C0E-991C-872DBB7459A8}" type="datetimeFigureOut">
               <a:rPr lang="da-DK" smtClean="0"/>
-              <a:t>06-02-2025</a:t>
+              <a:t>26-02-2025</a:t>
             </a:fld>
             <a:endParaRPr lang="da-DK"/>
           </a:p>
@@ -684,13 +684,13 @@
   <p:clrMapOvr>
     <a:masterClrMapping/>
   </p:clrMapOvr>
-  <mc:AlternateContent xmlns:mc="http://schemas.openxmlformats.org/markup-compatibility/2006">
-    <mc:Choice xmlns:p14="http://schemas.microsoft.com/office/powerpoint/2010/main" Requires="p14">
+  <mc:AlternateContent xmlns:mc="http://schemas.openxmlformats.org/markup-compatibility/2006" xmlns:p14="http://schemas.microsoft.com/office/powerpoint/2010/main">
+    <mc:Choice Requires="p14">
       <p:transition spd="med" p14:dur="700">
         <p:fade/>
       </p:transition>
     </mc:Choice>
-    <mc:Fallback>
+    <mc:Fallback xmlns="">
       <p:transition spd="med">
         <p:fade/>
       </p:transition>
@@ -806,7 +806,7 @@
           <a:p>
             <a:fld id="{E15B7D8E-2A20-4C0E-991C-872DBB7459A8}" type="datetimeFigureOut">
               <a:rPr lang="da-DK" smtClean="0"/>
-              <a:t>06-02-2025</a:t>
+              <a:t>26-02-2025</a:t>
             </a:fld>
             <a:endParaRPr lang="da-DK"/>
           </a:p>
@@ -864,13 +864,13 @@
   <p:clrMapOvr>
     <a:masterClrMapping/>
   </p:clrMapOvr>
-  <mc:AlternateContent xmlns:mc="http://schemas.openxmlformats.org/markup-compatibility/2006">
-    <mc:Choice xmlns:p14="http://schemas.microsoft.com/office/powerpoint/2010/main" Requires="p14">
+  <mc:AlternateContent xmlns:mc="http://schemas.openxmlformats.org/markup-compatibility/2006" xmlns:p14="http://schemas.microsoft.com/office/powerpoint/2010/main">
+    <mc:Choice Requires="p14">
       <p:transition spd="med" p14:dur="700">
         <p:fade/>
       </p:transition>
     </mc:Choice>
-    <mc:Fallback>
+    <mc:Fallback xmlns="">
       <p:transition spd="med">
         <p:fade/>
       </p:transition>
@@ -1063,7 +1063,7 @@
           <a:p>
             <a:fld id="{E15B7D8E-2A20-4C0E-991C-872DBB7459A8}" type="datetimeFigureOut">
               <a:rPr lang="da-DK" smtClean="0"/>
-              <a:t>06-02-2025</a:t>
+              <a:t>26-02-2025</a:t>
             </a:fld>
             <a:endParaRPr lang="da-DK"/>
           </a:p>
@@ -1121,13 +1121,13 @@
   <p:clrMapOvr>
     <a:masterClrMapping/>
   </p:clrMapOvr>
-  <mc:AlternateContent xmlns:mc="http://schemas.openxmlformats.org/markup-compatibility/2006">
-    <mc:Choice xmlns:p14="http://schemas.microsoft.com/office/powerpoint/2010/main" Requires="p14">
+  <mc:AlternateContent xmlns:mc="http://schemas.openxmlformats.org/markup-compatibility/2006" xmlns:p14="http://schemas.microsoft.com/office/powerpoint/2010/main">
+    <mc:Choice Requires="p14">
       <p:transition spd="med" p14:dur="700">
         <p:fade/>
       </p:transition>
     </mc:Choice>
-    <mc:Fallback>
+    <mc:Fallback xmlns="">
       <p:transition spd="med">
         <p:fade/>
       </p:transition>
@@ -1304,7 +1304,7 @@
           <a:p>
             <a:fld id="{E15B7D8E-2A20-4C0E-991C-872DBB7459A8}" type="datetimeFigureOut">
               <a:rPr lang="da-DK" smtClean="0"/>
-              <a:t>06-02-2025</a:t>
+              <a:t>26-02-2025</a:t>
             </a:fld>
             <a:endParaRPr lang="da-DK"/>
           </a:p>
@@ -1362,13 +1362,13 @@
   <p:clrMapOvr>
     <a:masterClrMapping/>
   </p:clrMapOvr>
-  <mc:AlternateContent xmlns:mc="http://schemas.openxmlformats.org/markup-compatibility/2006">
-    <mc:Choice xmlns:p14="http://schemas.microsoft.com/office/powerpoint/2010/main" Requires="p14">
+  <mc:AlternateContent xmlns:mc="http://schemas.openxmlformats.org/markup-compatibility/2006" xmlns:p14="http://schemas.microsoft.com/office/powerpoint/2010/main">
+    <mc:Choice Requires="p14">
       <p:transition spd="med" p14:dur="700">
         <p:fade/>
       </p:transition>
     </mc:Choice>
-    <mc:Fallback>
+    <mc:Fallback xmlns="">
       <p:transition spd="med">
         <p:fade/>
       </p:transition>
@@ -1680,7 +1680,7 @@
           <a:p>
             <a:fld id="{E15B7D8E-2A20-4C0E-991C-872DBB7459A8}" type="datetimeFigureOut">
               <a:rPr lang="da-DK" smtClean="0"/>
-              <a:t>06-02-2025</a:t>
+              <a:t>26-02-2025</a:t>
             </a:fld>
             <a:endParaRPr lang="da-DK"/>
           </a:p>
@@ -1738,13 +1738,13 @@
   <p:clrMapOvr>
     <a:masterClrMapping/>
   </p:clrMapOvr>
-  <mc:AlternateContent xmlns:mc="http://schemas.openxmlformats.org/markup-compatibility/2006">
-    <mc:Choice xmlns:p14="http://schemas.microsoft.com/office/powerpoint/2010/main" Requires="p14">
+  <mc:AlternateContent xmlns:mc="http://schemas.openxmlformats.org/markup-compatibility/2006" xmlns:p14="http://schemas.microsoft.com/office/powerpoint/2010/main">
+    <mc:Choice Requires="p14">
       <p:transition spd="med" p14:dur="700">
         <p:fade/>
       </p:transition>
     </mc:Choice>
-    <mc:Fallback>
+    <mc:Fallback xmlns="">
       <p:transition spd="med">
         <p:fade/>
       </p:transition>
@@ -1809,7 +1809,7 @@
           <a:p>
             <a:fld id="{E15B7D8E-2A20-4C0E-991C-872DBB7459A8}" type="datetimeFigureOut">
               <a:rPr lang="da-DK" smtClean="0"/>
-              <a:t>06-02-2025</a:t>
+              <a:t>26-02-2025</a:t>
             </a:fld>
             <a:endParaRPr lang="da-DK"/>
           </a:p>
@@ -1867,13 +1867,13 @@
   <p:clrMapOvr>
     <a:masterClrMapping/>
   </p:clrMapOvr>
-  <mc:AlternateContent xmlns:mc="http://schemas.openxmlformats.org/markup-compatibility/2006">
-    <mc:Choice xmlns:p14="http://schemas.microsoft.com/office/powerpoint/2010/main" Requires="p14">
+  <mc:AlternateContent xmlns:mc="http://schemas.openxmlformats.org/markup-compatibility/2006" xmlns:p14="http://schemas.microsoft.com/office/powerpoint/2010/main">
+    <mc:Choice Requires="p14">
       <p:transition spd="med" p14:dur="700">
         <p:fade/>
       </p:transition>
     </mc:Choice>
-    <mc:Fallback>
+    <mc:Fallback xmlns="">
       <p:transition spd="med">
         <p:fade/>
       </p:transition>
@@ -1916,7 +1916,7 @@
           <a:p>
             <a:fld id="{E15B7D8E-2A20-4C0E-991C-872DBB7459A8}" type="datetimeFigureOut">
               <a:rPr lang="da-DK" smtClean="0"/>
-              <a:t>06-02-2025</a:t>
+              <a:t>26-02-2025</a:t>
             </a:fld>
             <a:endParaRPr lang="da-DK"/>
           </a:p>
@@ -1974,13 +1974,13 @@
   <p:clrMapOvr>
     <a:masterClrMapping/>
   </p:clrMapOvr>
-  <mc:AlternateContent xmlns:mc="http://schemas.openxmlformats.org/markup-compatibility/2006">
-    <mc:Choice xmlns:p14="http://schemas.microsoft.com/office/powerpoint/2010/main" Requires="p14">
+  <mc:AlternateContent xmlns:mc="http://schemas.openxmlformats.org/markup-compatibility/2006" xmlns:p14="http://schemas.microsoft.com/office/powerpoint/2010/main">
+    <mc:Choice Requires="p14">
       <p:transition spd="med" p14:dur="700">
         <p:fade/>
       </p:transition>
     </mc:Choice>
-    <mc:Fallback>
+    <mc:Fallback xmlns="">
       <p:transition spd="med">
         <p:fade/>
       </p:transition>
@@ -2203,7 +2203,7 @@
           <a:p>
             <a:fld id="{E15B7D8E-2A20-4C0E-991C-872DBB7459A8}" type="datetimeFigureOut">
               <a:rPr lang="da-DK" smtClean="0"/>
-              <a:t>06-02-2025</a:t>
+              <a:t>26-02-2025</a:t>
             </a:fld>
             <a:endParaRPr lang="da-DK"/>
           </a:p>
@@ -2261,13 +2261,13 @@
   <p:clrMapOvr>
     <a:masterClrMapping/>
   </p:clrMapOvr>
-  <mc:AlternateContent xmlns:mc="http://schemas.openxmlformats.org/markup-compatibility/2006">
-    <mc:Choice xmlns:p14="http://schemas.microsoft.com/office/powerpoint/2010/main" Requires="p14">
+  <mc:AlternateContent xmlns:mc="http://schemas.openxmlformats.org/markup-compatibility/2006" xmlns:p14="http://schemas.microsoft.com/office/powerpoint/2010/main">
+    <mc:Choice Requires="p14">
       <p:transition spd="med" p14:dur="700">
         <p:fade/>
       </p:transition>
     </mc:Choice>
-    <mc:Fallback>
+    <mc:Fallback xmlns="">
       <p:transition spd="med">
         <p:fade/>
       </p:transition>
@@ -2467,7 +2467,7 @@
           <a:p>
             <a:fld id="{E15B7D8E-2A20-4C0E-991C-872DBB7459A8}" type="datetimeFigureOut">
               <a:rPr lang="da-DK" smtClean="0"/>
-              <a:t>06-02-2025</a:t>
+              <a:t>26-02-2025</a:t>
             </a:fld>
             <a:endParaRPr lang="da-DK"/>
           </a:p>
@@ -2525,13 +2525,13 @@
   <p:clrMapOvr>
     <a:masterClrMapping/>
   </p:clrMapOvr>
-  <mc:AlternateContent xmlns:mc="http://schemas.openxmlformats.org/markup-compatibility/2006">
-    <mc:Choice xmlns:p14="http://schemas.microsoft.com/office/powerpoint/2010/main" Requires="p14">
+  <mc:AlternateContent xmlns:mc="http://schemas.openxmlformats.org/markup-compatibility/2006" xmlns:p14="http://schemas.microsoft.com/office/powerpoint/2010/main">
+    <mc:Choice Requires="p14">
       <p:transition spd="med" p14:dur="700">
         <p:fade/>
       </p:transition>
     </mc:Choice>
-    <mc:Fallback>
+    <mc:Fallback xmlns="">
       <p:transition spd="med">
         <p:fade/>
       </p:transition>
@@ -2690,7 +2690,7 @@
           <a:p>
             <a:fld id="{E15B7D8E-2A20-4C0E-991C-872DBB7459A8}" type="datetimeFigureOut">
               <a:rPr lang="da-DK" smtClean="0"/>
-              <a:t>06-02-2025</a:t>
+              <a:t>26-02-2025</a:t>
             </a:fld>
             <a:endParaRPr lang="da-DK"/>
           </a:p>
@@ -2795,13 +2795,13 @@
     <p:sldLayoutId id="2147483658" r:id="rId10"/>
     <p:sldLayoutId id="2147483659" r:id="rId11"/>
   </p:sldLayoutIdLst>
-  <mc:AlternateContent xmlns:mc="http://schemas.openxmlformats.org/markup-compatibility/2006">
-    <mc:Choice xmlns:p14="http://schemas.microsoft.com/office/powerpoint/2010/main" Requires="p14">
+  <mc:AlternateContent xmlns:mc="http://schemas.openxmlformats.org/markup-compatibility/2006" xmlns:p14="http://schemas.microsoft.com/office/powerpoint/2010/main">
+    <mc:Choice Requires="p14">
       <p:transition spd="med" p14:dur="700">
         <p:fade/>
       </p:transition>
     </mc:Choice>
-    <mc:Fallback>
+    <mc:Fallback xmlns="">
       <p:transition spd="med">
         <p:fade/>
       </p:transition>
@@ -3156,13 +3156,13 @@
   <p:clrMapOvr>
     <a:masterClrMapping/>
   </p:clrMapOvr>
-  <mc:AlternateContent xmlns:mc="http://schemas.openxmlformats.org/markup-compatibility/2006">
-    <mc:Choice xmlns:p14="http://schemas.microsoft.com/office/powerpoint/2010/main" Requires="p14">
+  <mc:AlternateContent xmlns:mc="http://schemas.openxmlformats.org/markup-compatibility/2006" xmlns:p14="http://schemas.microsoft.com/office/powerpoint/2010/main">
+    <mc:Choice Requires="p14">
       <p:transition spd="med" p14:dur="700">
         <p:fade/>
       </p:transition>
     </mc:Choice>
-    <mc:Fallback>
+    <mc:Fallback xmlns="">
       <p:transition spd="med">
         <p:fade/>
       </p:transition>
@@ -3726,13 +3726,13 @@
   <p:clrMapOvr>
     <a:masterClrMapping/>
   </p:clrMapOvr>
-  <mc:AlternateContent xmlns:mc="http://schemas.openxmlformats.org/markup-compatibility/2006">
-    <mc:Choice xmlns:p14="http://schemas.microsoft.com/office/powerpoint/2010/main" Requires="p14">
+  <mc:AlternateContent xmlns:mc="http://schemas.openxmlformats.org/markup-compatibility/2006" xmlns:p14="http://schemas.microsoft.com/office/powerpoint/2010/main">
+    <mc:Choice Requires="p14">
       <p:transition spd="med" p14:dur="700">
         <p:fade/>
       </p:transition>
     </mc:Choice>
-    <mc:Fallback>
+    <mc:Fallback xmlns="">
       <p:transition spd="med">
         <p:fade/>
       </p:transition>
@@ -3863,13 +3863,13 @@
   <p:clrMapOvr>
     <a:masterClrMapping/>
   </p:clrMapOvr>
-  <mc:AlternateContent xmlns:mc="http://schemas.openxmlformats.org/markup-compatibility/2006">
-    <mc:Choice xmlns:p14="http://schemas.microsoft.com/office/powerpoint/2010/main" Requires="p14">
+  <mc:AlternateContent xmlns:mc="http://schemas.openxmlformats.org/markup-compatibility/2006" xmlns:p14="http://schemas.microsoft.com/office/powerpoint/2010/main">
+    <mc:Choice Requires="p14">
       <p:transition spd="med" p14:dur="700">
         <p:fade/>
       </p:transition>
     </mc:Choice>
-    <mc:Fallback>
+    <mc:Fallback xmlns="">
       <p:transition spd="med">
         <p:fade/>
       </p:transition>
@@ -3989,13 +3989,13 @@
   <p:clrMapOvr>
     <a:masterClrMapping/>
   </p:clrMapOvr>
-  <mc:AlternateContent xmlns:mc="http://schemas.openxmlformats.org/markup-compatibility/2006">
-    <mc:Choice xmlns:p14="http://schemas.microsoft.com/office/powerpoint/2010/main" Requires="p14">
+  <mc:AlternateContent xmlns:mc="http://schemas.openxmlformats.org/markup-compatibility/2006" xmlns:p14="http://schemas.microsoft.com/office/powerpoint/2010/main">
+    <mc:Choice Requires="p14">
       <p:transition spd="med" p14:dur="700">
         <p:fade/>
       </p:transition>
     </mc:Choice>
-    <mc:Fallback>
+    <mc:Fallback xmlns="">
       <p:transition spd="med">
         <p:fade/>
       </p:transition>
@@ -4144,13 +4144,13 @@
   <p:clrMapOvr>
     <a:masterClrMapping/>
   </p:clrMapOvr>
-  <mc:AlternateContent xmlns:mc="http://schemas.openxmlformats.org/markup-compatibility/2006">
-    <mc:Choice xmlns:p14="http://schemas.microsoft.com/office/powerpoint/2010/main" Requires="p14">
+  <mc:AlternateContent xmlns:mc="http://schemas.openxmlformats.org/markup-compatibility/2006" xmlns:p14="http://schemas.microsoft.com/office/powerpoint/2010/main">
+    <mc:Choice Requires="p14">
       <p:transition spd="med" p14:dur="700">
         <p:fade/>
       </p:transition>
     </mc:Choice>
-    <mc:Fallback>
+    <mc:Fallback xmlns="">
       <p:transition spd="med">
         <p:fade/>
       </p:transition>
@@ -4185,7 +4185,7 @@
           <p:nvPr>
             <p:extLst>
               <p:ext uri="{D42A27DB-BD31-4B8C-83A1-F6EECF244321}">
-                <p14:modId xmlns:p14="http://schemas.microsoft.com/office/powerpoint/2010/main" val="1840519709"/>
+                <p14:modId xmlns:p14="http://schemas.microsoft.com/office/powerpoint/2010/main" val="1028230815"/>
               </p:ext>
             </p:extLst>
           </p:nvPr>
@@ -4239,7 +4239,7 @@
                       <a:pPr algn="l"/>
                       <a:r>
                         <a:rPr lang="da-DK" sz="1600"/>
-                        <a:t>People</a:t>
+                        <a:t>Employee</a:t>
                       </a:r>
                     </a:p>
                   </a:txBody>
@@ -7806,13 +7806,13 @@
   <p:clrMapOvr>
     <a:masterClrMapping/>
   </p:clrMapOvr>
-  <mc:AlternateContent xmlns:mc="http://schemas.openxmlformats.org/markup-compatibility/2006">
-    <mc:Choice xmlns:p14="http://schemas.microsoft.com/office/powerpoint/2010/main" Requires="p14">
+  <mc:AlternateContent xmlns:mc="http://schemas.openxmlformats.org/markup-compatibility/2006" xmlns:p14="http://schemas.microsoft.com/office/powerpoint/2010/main">
+    <mc:Choice Requires="p14">
       <p:transition spd="med" p14:dur="700">
         <p:fade/>
       </p:transition>
     </mc:Choice>
-    <mc:Fallback>
+    <mc:Fallback xmlns="">
       <p:transition spd="med">
         <p:fade/>
       </p:transition>
@@ -8060,13 +8060,13 @@
   <p:clrMapOvr>
     <a:masterClrMapping/>
   </p:clrMapOvr>
-  <mc:AlternateContent xmlns:mc="http://schemas.openxmlformats.org/markup-compatibility/2006">
-    <mc:Choice xmlns:p14="http://schemas.microsoft.com/office/powerpoint/2010/main" Requires="p14">
+  <mc:AlternateContent xmlns:mc="http://schemas.openxmlformats.org/markup-compatibility/2006" xmlns:p14="http://schemas.microsoft.com/office/powerpoint/2010/main">
+    <mc:Choice Requires="p14">
       <p:transition spd="med" p14:dur="700">
         <p:fade/>
       </p:transition>
     </mc:Choice>
-    <mc:Fallback>
+    <mc:Fallback xmlns="">
       <p:transition spd="med">
         <p:fade/>
       </p:transition>
@@ -8244,13 +8244,13 @@
   <p:clrMapOvr>
     <a:masterClrMapping/>
   </p:clrMapOvr>
-  <mc:AlternateContent xmlns:mc="http://schemas.openxmlformats.org/markup-compatibility/2006">
-    <mc:Choice xmlns:p14="http://schemas.microsoft.com/office/powerpoint/2010/main" Requires="p14">
+  <mc:AlternateContent xmlns:mc="http://schemas.openxmlformats.org/markup-compatibility/2006" xmlns:p14="http://schemas.microsoft.com/office/powerpoint/2010/main">
+    <mc:Choice Requires="p14">
       <p:transition spd="med" p14:dur="700">
         <p:fade/>
       </p:transition>
     </mc:Choice>
-    <mc:Fallback>
+    <mc:Fallback xmlns="">
       <p:transition spd="med">
         <p:fade/>
       </p:transition>
@@ -8285,7 +8285,7 @@
           <p:nvPr>
             <p:extLst>
               <p:ext uri="{D42A27DB-BD31-4B8C-83A1-F6EECF244321}">
-                <p14:modId xmlns:p14="http://schemas.microsoft.com/office/powerpoint/2010/main" val="690434222"/>
+                <p14:modId xmlns:p14="http://schemas.microsoft.com/office/powerpoint/2010/main" val="81285607"/>
               </p:ext>
             </p:extLst>
           </p:nvPr>
@@ -8339,7 +8339,7 @@
                       <a:pPr algn="l"/>
                       <a:r>
                         <a:rPr lang="da-DK" sz="3200"/>
-                        <a:t>People</a:t>
+                        <a:t>Employee</a:t>
                       </a:r>
                     </a:p>
                   </a:txBody>
@@ -10834,13 +10834,13 @@
   <p:clrMapOvr>
     <a:masterClrMapping/>
   </p:clrMapOvr>
-  <mc:AlternateContent xmlns:mc="http://schemas.openxmlformats.org/markup-compatibility/2006">
-    <mc:Choice xmlns:p14="http://schemas.microsoft.com/office/powerpoint/2010/main" Requires="p14">
+  <mc:AlternateContent xmlns:mc="http://schemas.openxmlformats.org/markup-compatibility/2006" xmlns:p14="http://schemas.microsoft.com/office/powerpoint/2010/main">
+    <mc:Choice Requires="p14">
       <p:transition spd="med" p14:dur="700">
         <p:fade/>
       </p:transition>
     </mc:Choice>
-    <mc:Fallback>
+    <mc:Fallback xmlns="">
       <p:transition spd="med">
         <p:fade/>
       </p:transition>
@@ -10875,7 +10875,7 @@
           <p:nvPr>
             <p:extLst>
               <p:ext uri="{D42A27DB-BD31-4B8C-83A1-F6EECF244321}">
-                <p14:modId xmlns:p14="http://schemas.microsoft.com/office/powerpoint/2010/main" val="2208127807"/>
+                <p14:modId xmlns:p14="http://schemas.microsoft.com/office/powerpoint/2010/main" val="2035837385"/>
               </p:ext>
             </p:extLst>
           </p:nvPr>
@@ -10929,7 +10929,7 @@
                       <a:pPr algn="l"/>
                       <a:r>
                         <a:rPr lang="da-DK" sz="3200"/>
-                        <a:t>People</a:t>
+                        <a:t>Employee</a:t>
                       </a:r>
                     </a:p>
                   </a:txBody>
@@ -13575,13 +13575,13 @@
   <p:clrMapOvr>
     <a:masterClrMapping/>
   </p:clrMapOvr>
-  <mc:AlternateContent xmlns:mc="http://schemas.openxmlformats.org/markup-compatibility/2006">
-    <mc:Choice xmlns:p14="http://schemas.microsoft.com/office/powerpoint/2010/main" Requires="p14">
+  <mc:AlternateContent xmlns:mc="http://schemas.openxmlformats.org/markup-compatibility/2006" xmlns:p14="http://schemas.microsoft.com/office/powerpoint/2010/main">
+    <mc:Choice Requires="p14">
       <p:transition spd="med" p14:dur="700">
         <p:fade/>
       </p:transition>
     </mc:Choice>
-    <mc:Fallback>
+    <mc:Fallback xmlns="">
       <p:transition spd="med">
         <p:fade/>
       </p:transition>
@@ -13616,7 +13616,7 @@
           <p:nvPr>
             <p:extLst>
               <p:ext uri="{D42A27DB-BD31-4B8C-83A1-F6EECF244321}">
-                <p14:modId xmlns:p14="http://schemas.microsoft.com/office/powerpoint/2010/main" val="2649109152"/>
+                <p14:modId xmlns:p14="http://schemas.microsoft.com/office/powerpoint/2010/main" val="3728065945"/>
               </p:ext>
             </p:extLst>
           </p:nvPr>
@@ -13670,7 +13670,7 @@
                       <a:pPr algn="l"/>
                       <a:r>
                         <a:rPr lang="da-DK" sz="3200"/>
-                        <a:t>People</a:t>
+                        <a:t>Employee</a:t>
                       </a:r>
                     </a:p>
                   </a:txBody>
@@ -15740,13 +15740,13 @@
   <p:clrMapOvr>
     <a:masterClrMapping/>
   </p:clrMapOvr>
-  <mc:AlternateContent xmlns:mc="http://schemas.openxmlformats.org/markup-compatibility/2006">
-    <mc:Choice xmlns:p14="http://schemas.microsoft.com/office/powerpoint/2010/main" Requires="p14">
+  <mc:AlternateContent xmlns:mc="http://schemas.openxmlformats.org/markup-compatibility/2006" xmlns:p14="http://schemas.microsoft.com/office/powerpoint/2010/main">
+    <mc:Choice Requires="p14">
       <p:transition spd="med" p14:dur="700">
         <p:fade/>
       </p:transition>
     </mc:Choice>
-    <mc:Fallback>
+    <mc:Fallback xmlns="">
       <p:transition spd="med">
         <p:fade/>
       </p:transition>
@@ -15781,7 +15781,7 @@
           <p:nvPr>
             <p:extLst>
               <p:ext uri="{D42A27DB-BD31-4B8C-83A1-F6EECF244321}">
-                <p14:modId xmlns:p14="http://schemas.microsoft.com/office/powerpoint/2010/main" val="3356713191"/>
+                <p14:modId xmlns:p14="http://schemas.microsoft.com/office/powerpoint/2010/main" val="3737277015"/>
               </p:ext>
             </p:extLst>
           </p:nvPr>
@@ -15835,7 +15835,7 @@
                       <a:pPr algn="l"/>
                       <a:r>
                         <a:rPr lang="da-DK" sz="3200"/>
-                        <a:t>People</a:t>
+                        <a:t>Employee</a:t>
                       </a:r>
                     </a:p>
                   </a:txBody>
@@ -18056,13 +18056,13 @@
   <p:clrMapOvr>
     <a:masterClrMapping/>
   </p:clrMapOvr>
-  <mc:AlternateContent xmlns:mc="http://schemas.openxmlformats.org/markup-compatibility/2006">
-    <mc:Choice xmlns:p14="http://schemas.microsoft.com/office/powerpoint/2010/main" Requires="p14">
+  <mc:AlternateContent xmlns:mc="http://schemas.openxmlformats.org/markup-compatibility/2006" xmlns:p14="http://schemas.microsoft.com/office/powerpoint/2010/main">
+    <mc:Choice Requires="p14">
       <p:transition spd="med" p14:dur="700">
         <p:fade/>
       </p:transition>
     </mc:Choice>
-    <mc:Fallback>
+    <mc:Fallback xmlns="">
       <p:transition spd="med">
         <p:fade/>
       </p:transition>
@@ -18097,7 +18097,7 @@
           <p:nvPr>
             <p:extLst>
               <p:ext uri="{D42A27DB-BD31-4B8C-83A1-F6EECF244321}">
-                <p14:modId xmlns:p14="http://schemas.microsoft.com/office/powerpoint/2010/main" val="2405028037"/>
+                <p14:modId xmlns:p14="http://schemas.microsoft.com/office/powerpoint/2010/main" val="47477128"/>
               </p:ext>
             </p:extLst>
           </p:nvPr>
@@ -18137,7 +18137,7 @@
                       <a:pPr algn="l"/>
                       <a:r>
                         <a:rPr lang="da-DK" sz="3200"/>
-                        <a:t>People</a:t>
+                        <a:t>Employee</a:t>
                       </a:r>
                     </a:p>
                   </a:txBody>
@@ -19430,13 +19430,13 @@
   <p:clrMapOvr>
     <a:masterClrMapping/>
   </p:clrMapOvr>
-  <mc:AlternateContent xmlns:mc="http://schemas.openxmlformats.org/markup-compatibility/2006">
-    <mc:Choice xmlns:p14="http://schemas.microsoft.com/office/powerpoint/2010/main" Requires="p14">
+  <mc:AlternateContent xmlns:mc="http://schemas.openxmlformats.org/markup-compatibility/2006" xmlns:p14="http://schemas.microsoft.com/office/powerpoint/2010/main">
+    <mc:Choice Requires="p14">
       <p:transition spd="med" p14:dur="700">
         <p:fade/>
       </p:transition>
     </mc:Choice>
-    <mc:Fallback>
+    <mc:Fallback xmlns="">
       <p:transition spd="med">
         <p:fade/>
       </p:transition>
@@ -19560,13 +19560,13 @@
   <p:clrMapOvr>
     <a:masterClrMapping/>
   </p:clrMapOvr>
-  <mc:AlternateContent xmlns:mc="http://schemas.openxmlformats.org/markup-compatibility/2006">
-    <mc:Choice xmlns:p14="http://schemas.microsoft.com/office/powerpoint/2010/main" Requires="p14">
+  <mc:AlternateContent xmlns:mc="http://schemas.openxmlformats.org/markup-compatibility/2006" xmlns:p14="http://schemas.microsoft.com/office/powerpoint/2010/main">
+    <mc:Choice Requires="p14">
       <p:transition spd="med" p14:dur="700">
         <p:fade/>
       </p:transition>
     </mc:Choice>
-    <mc:Fallback>
+    <mc:Fallback xmlns="">
       <p:transition spd="med">
         <p:fade/>
       </p:transition>
@@ -20138,13 +20138,13 @@
   <p:clrMapOvr>
     <a:masterClrMapping/>
   </p:clrMapOvr>
-  <mc:AlternateContent xmlns:mc="http://schemas.openxmlformats.org/markup-compatibility/2006">
-    <mc:Choice xmlns:p14="http://schemas.microsoft.com/office/powerpoint/2010/main" Requires="p14">
+  <mc:AlternateContent xmlns:mc="http://schemas.openxmlformats.org/markup-compatibility/2006" xmlns:p14="http://schemas.microsoft.com/office/powerpoint/2010/main">
+    <mc:Choice Requires="p14">
       <p:transition spd="med" p14:dur="700">
         <p:fade/>
       </p:transition>
     </mc:Choice>
-    <mc:Fallback>
+    <mc:Fallback xmlns="">
       <p:transition spd="med">
         <p:fade/>
       </p:transition>
@@ -20603,13 +20603,13 @@
   <p:clrMapOvr>
     <a:masterClrMapping/>
   </p:clrMapOvr>
-  <mc:AlternateContent xmlns:mc="http://schemas.openxmlformats.org/markup-compatibility/2006">
-    <mc:Choice xmlns:p14="http://schemas.microsoft.com/office/powerpoint/2010/main" Requires="p14">
+  <mc:AlternateContent xmlns:mc="http://schemas.openxmlformats.org/markup-compatibility/2006" xmlns:p14="http://schemas.microsoft.com/office/powerpoint/2010/main">
+    <mc:Choice Requires="p14">
       <p:transition spd="med" p14:dur="700">
         <p:fade/>
       </p:transition>
     </mc:Choice>
-    <mc:Fallback>
+    <mc:Fallback xmlns="">
       <p:transition spd="med">
         <p:fade/>
       </p:transition>

</xml_diff>